<commit_message>
docs: expand report and slide evidence
Add self-contained Overleaf figures and strengthen the methodology/results narrative. Update cleaning justification, slide generation logic, and regenerated slide artifacts.
</commit_message>
<xml_diff>
--- a/reports/slides.pptx
+++ b/reports/slides.pptx
@@ -6768,7 +6768,7 @@
         <p:spPr>
           <a:xfrm>
             <a:off x="457200" y="4206240"/>
-            <a:ext cx="6858000" cy="1828800"/>
+            <a:ext cx="6858000" cy="1920240"/>
           </a:xfrm>
           <a:prstGeom prst="rect">
             <a:avLst/>
@@ -6783,12 +6783,13 @@
           <a:p>
             <a:pPr algn="l"/>
             <a:r>
-              <a:rPr sz="1400" b="0">
+              <a:rPr sz="1300" b="0">
                 <a:solidFill>
                   <a:srgbClr val="1F1F1F"/>
                 </a:solidFill>
               </a:rPr>
-              <a:t>Pattern: customers who buy one item from a colour or themed set frequently complete the set. Operational use: post-purchase recommendations and bundled retention offers.</a:t>
+              <a:t>Pattern: customers who buy one item from a colour or themed set frequently complete the set. Operational use: post-purchase recommendations and bundled retention offers.
+Rules are mined on customer-attributed invoices only — consistent with the per-segment rules, and excluding anonymous wholesale/bulk baskets.</a:t>
             </a:r>
           </a:p>
         </p:txBody>
@@ -7231,17 +7232,414 @@
         </p:blipFill>
         <p:spPr>
           <a:xfrm>
-            <a:off x="548640" y="1280160"/>
-            <a:ext cx="6858000" cy="4359705"/>
+            <a:off x="457200" y="1280160"/>
+            <a:ext cx="4890525" cy="3108960"/>
           </a:xfrm>
           <a:prstGeom prst="rect">
             <a:avLst/>
           </a:prstGeom>
         </p:spPr>
       </p:pic>
-      <p:sp>
-        <p:nvSpPr>
-          <p:cNvPr id="5" name="Rounded Rectangle 4"/>
+      <p:graphicFrame>
+        <p:nvGraphicFramePr>
+          <p:cNvPr id="5" name="Table 4"/>
+          <p:cNvGraphicFramePr>
+            <a:graphicFrameLocks noGrp="1"/>
+          </p:cNvGraphicFramePr>
+          <p:nvPr/>
+        </p:nvGraphicFramePr>
+        <p:xfrm>
+          <a:off x="457200" y="4572000"/>
+          <a:ext cx="7132320" cy="1463040"/>
+        </p:xfrm>
+        <a:graphic>
+          <a:graphicData uri="http://schemas.openxmlformats.org/drawingml/2006/table">
+            <a:tbl>
+              <a:tblPr firstRow="1" bandRow="1">
+                <a:tableStyleId>{5C22544A-7EE6-4342-B048-85BDC9FD1C3A}</a:tableStyleId>
+              </a:tblPr>
+              <a:tblGrid>
+                <a:gridCol w="1426464"/>
+                <a:gridCol w="1426464"/>
+                <a:gridCol w="1426464"/>
+                <a:gridCol w="1426464"/>
+                <a:gridCol w="1426464"/>
+              </a:tblGrid>
+              <a:tr h="365760">
+                <a:tc>
+                  <a:txBody>
+                    <a:bodyPr/>
+                    <a:lstStyle/>
+                    <a:p>
+                      <a:r>
+                        <a:rPr sz="1200" b="1">
+                          <a:solidFill>
+                            <a:srgbClr val="FFFFFF"/>
+                          </a:solidFill>
+                        </a:rPr>
+                        <a:t>Segment</a:t>
+                      </a:r>
+                    </a:p>
+                  </a:txBody>
+                  <a:tcPr>
+                    <a:solidFill>
+                      <a:srgbClr val="264653"/>
+                    </a:solidFill>
+                  </a:tcPr>
+                </a:tc>
+                <a:tc>
+                  <a:txBody>
+                    <a:bodyPr/>
+                    <a:lstStyle/>
+                    <a:p>
+                      <a:r>
+                        <a:rPr sz="1200" b="1">
+                          <a:solidFill>
+                            <a:srgbClr val="FFFFFF"/>
+                          </a:solidFill>
+                        </a:rPr>
+                        <a:t>n</a:t>
+                      </a:r>
+                    </a:p>
+                  </a:txBody>
+                  <a:tcPr>
+                    <a:solidFill>
+                      <a:srgbClr val="264653"/>
+                    </a:solidFill>
+                  </a:tcPr>
+                </a:tc>
+                <a:tc>
+                  <a:txBody>
+                    <a:bodyPr/>
+                    <a:lstStyle/>
+                    <a:p>
+                      <a:r>
+                        <a:rPr sz="1200" b="1">
+                          <a:solidFill>
+                            <a:srgbClr val="FFFFFF"/>
+                          </a:solidFill>
+                        </a:rPr>
+                        <a:t>Churn %</a:t>
+                      </a:r>
+                    </a:p>
+                  </a:txBody>
+                  <a:tcPr>
+                    <a:solidFill>
+                      <a:srgbClr val="264653"/>
+                    </a:solidFill>
+                  </a:tcPr>
+                </a:tc>
+                <a:tc>
+                  <a:txBody>
+                    <a:bodyPr/>
+                    <a:lstStyle/>
+                    <a:p>
+                      <a:r>
+                        <a:rPr sz="1200" b="1">
+                          <a:solidFill>
+                            <a:srgbClr val="FFFFFF"/>
+                          </a:solidFill>
+                        </a:rPr>
+                        <a:t>Avg Recency</a:t>
+                      </a:r>
+                    </a:p>
+                  </a:txBody>
+                  <a:tcPr>
+                    <a:solidFill>
+                      <a:srgbClr val="264653"/>
+                    </a:solidFill>
+                  </a:tcPr>
+                </a:tc>
+                <a:tc>
+                  <a:txBody>
+                    <a:bodyPr/>
+                    <a:lstStyle/>
+                    <a:p>
+                      <a:r>
+                        <a:rPr sz="1200" b="1">
+                          <a:solidFill>
+                            <a:srgbClr val="FFFFFF"/>
+                          </a:solidFill>
+                        </a:rPr>
+                        <a:t>Avg Monetary (£)</a:t>
+                      </a:r>
+                    </a:p>
+                  </a:txBody>
+                  <a:tcPr>
+                    <a:solidFill>
+                      <a:srgbClr val="264653"/>
+                    </a:solidFill>
+                  </a:tcPr>
+                </a:tc>
+              </a:tr>
+              <a:tr h="365760">
+                <a:tc>
+                  <a:txBody>
+                    <a:bodyPr/>
+                    <a:lstStyle/>
+                    <a:p>
+                      <a:r>
+                        <a:rPr sz="1200" b="0">
+                          <a:solidFill>
+                            <a:srgbClr val="1F1F1F"/>
+                          </a:solidFill>
+                        </a:rPr>
+                        <a:t>Dormant</a:t>
+                      </a:r>
+                    </a:p>
+                  </a:txBody>
+                  <a:tcPr/>
+                </a:tc>
+                <a:tc>
+                  <a:txBody>
+                    <a:bodyPr/>
+                    <a:lstStyle/>
+                    <a:p>
+                      <a:r>
+                        <a:rPr sz="1200" b="0">
+                          <a:solidFill>
+                            <a:srgbClr val="1F1F1F"/>
+                          </a:solidFill>
+                        </a:rPr>
+                        <a:t>2,697</a:t>
+                      </a:r>
+                    </a:p>
+                  </a:txBody>
+                  <a:tcPr/>
+                </a:tc>
+                <a:tc>
+                  <a:txBody>
+                    <a:bodyPr/>
+                    <a:lstStyle/>
+                    <a:p>
+                      <a:r>
+                        <a:rPr sz="1200" b="0">
+                          <a:solidFill>
+                            <a:srgbClr val="1F1F1F"/>
+                          </a:solidFill>
+                        </a:rPr>
+                        <a:t>90.0</a:t>
+                      </a:r>
+                    </a:p>
+                  </a:txBody>
+                  <a:tcPr/>
+                </a:tc>
+                <a:tc>
+                  <a:txBody>
+                    <a:bodyPr/>
+                    <a:lstStyle/>
+                    <a:p>
+                      <a:r>
+                        <a:rPr sz="1200" b="0">
+                          <a:solidFill>
+                            <a:srgbClr val="1F1F1F"/>
+                          </a:solidFill>
+                        </a:rPr>
+                        <a:t>367.9</a:t>
+                      </a:r>
+                    </a:p>
+                  </a:txBody>
+                  <a:tcPr/>
+                </a:tc>
+                <a:tc>
+                  <a:txBody>
+                    <a:bodyPr/>
+                    <a:lstStyle/>
+                    <a:p>
+                      <a:r>
+                        <a:rPr sz="1200" b="0">
+                          <a:solidFill>
+                            <a:srgbClr val="1F1F1F"/>
+                          </a:solidFill>
+                        </a:rPr>
+                        <a:t>519.5</a:t>
+                      </a:r>
+                    </a:p>
+                  </a:txBody>
+                  <a:tcPr/>
+                </a:tc>
+              </a:tr>
+              <a:tr h="365760">
+                <a:tc>
+                  <a:txBody>
+                    <a:bodyPr/>
+                    <a:lstStyle/>
+                    <a:p>
+                      <a:r>
+                        <a:rPr sz="1200" b="0">
+                          <a:solidFill>
+                            <a:srgbClr val="1F1F1F"/>
+                          </a:solidFill>
+                        </a:rPr>
+                        <a:t>Active loyal</a:t>
+                      </a:r>
+                    </a:p>
+                  </a:txBody>
+                  <a:tcPr/>
+                </a:tc>
+                <a:tc>
+                  <a:txBody>
+                    <a:bodyPr/>
+                    <a:lstStyle/>
+                    <a:p>
+                      <a:r>
+                        <a:rPr sz="1200" b="0">
+                          <a:solidFill>
+                            <a:srgbClr val="1F1F1F"/>
+                          </a:solidFill>
+                        </a:rPr>
+                        <a:t>2,552</a:t>
+                      </a:r>
+                    </a:p>
+                  </a:txBody>
+                  <a:tcPr/>
+                </a:tc>
+                <a:tc>
+                  <a:txBody>
+                    <a:bodyPr/>
+                    <a:lstStyle/>
+                    <a:p>
+                      <a:r>
+                        <a:rPr sz="1200" b="0">
+                          <a:solidFill>
+                            <a:srgbClr val="1F1F1F"/>
+                          </a:solidFill>
+                        </a:rPr>
+                        <a:t>23.0</a:t>
+                      </a:r>
+                    </a:p>
+                  </a:txBody>
+                  <a:tcPr/>
+                </a:tc>
+                <a:tc>
+                  <a:txBody>
+                    <a:bodyPr/>
+                    <a:lstStyle/>
+                    <a:p>
+                      <a:r>
+                        <a:rPr sz="1200" b="0">
+                          <a:solidFill>
+                            <a:srgbClr val="1F1F1F"/>
+                          </a:solidFill>
+                        </a:rPr>
+                        <a:t>65.2</a:t>
+                      </a:r>
+                    </a:p>
+                  </a:txBody>
+                  <a:tcPr/>
+                </a:tc>
+                <a:tc>
+                  <a:txBody>
+                    <a:bodyPr/>
+                    <a:lstStyle/>
+                    <a:p>
+                      <a:r>
+                        <a:rPr sz="1200" b="0">
+                          <a:solidFill>
+                            <a:srgbClr val="1F1F1F"/>
+                          </a:solidFill>
+                        </a:rPr>
+                        <a:t>5,401.2</a:t>
+                      </a:r>
+                    </a:p>
+                  </a:txBody>
+                  <a:tcPr/>
+                </a:tc>
+              </a:tr>
+              <a:tr h="365760">
+                <a:tc>
+                  <a:txBody>
+                    <a:bodyPr/>
+                    <a:lstStyle/>
+                    <a:p>
+                      <a:r>
+                        <a:rPr sz="1200" b="1">
+                          <a:solidFill>
+                            <a:srgbClr val="1F1F1F"/>
+                          </a:solidFill>
+                        </a:rPr>
+                        <a:t>Overall</a:t>
+                      </a:r>
+                    </a:p>
+                  </a:txBody>
+                  <a:tcPr/>
+                </a:tc>
+                <a:tc>
+                  <a:txBody>
+                    <a:bodyPr/>
+                    <a:lstStyle/>
+                    <a:p>
+                      <a:r>
+                        <a:rPr sz="1200" b="1">
+                          <a:solidFill>
+                            <a:srgbClr val="1F1F1F"/>
+                          </a:solidFill>
+                        </a:rPr>
+                        <a:t>5,249</a:t>
+                      </a:r>
+                    </a:p>
+                  </a:txBody>
+                  <a:tcPr/>
+                </a:tc>
+                <a:tc>
+                  <a:txBody>
+                    <a:bodyPr/>
+                    <a:lstStyle/>
+                    <a:p>
+                      <a:r>
+                        <a:rPr sz="1200" b="1">
+                          <a:solidFill>
+                            <a:srgbClr val="1F1F1F"/>
+                          </a:solidFill>
+                        </a:rPr>
+                        <a:t>57.4</a:t>
+                      </a:r>
+                    </a:p>
+                  </a:txBody>
+                  <a:tcPr/>
+                </a:tc>
+                <a:tc>
+                  <a:txBody>
+                    <a:bodyPr/>
+                    <a:lstStyle/>
+                    <a:p>
+                      <a:r>
+                        <a:rPr sz="1200" b="1">
+                          <a:solidFill>
+                            <a:srgbClr val="1F1F1F"/>
+                          </a:solidFill>
+                        </a:rPr>
+                        <a:t>—</a:t>
+                      </a:r>
+                    </a:p>
+                  </a:txBody>
+                  <a:tcPr/>
+                </a:tc>
+                <a:tc>
+                  <a:txBody>
+                    <a:bodyPr/>
+                    <a:lstStyle/>
+                    <a:p>
+                      <a:r>
+                        <a:rPr sz="1200" b="1">
+                          <a:solidFill>
+                            <a:srgbClr val="1F1F1F"/>
+                          </a:solidFill>
+                        </a:rPr>
+                        <a:t>—</a:t>
+                      </a:r>
+                    </a:p>
+                  </a:txBody>
+                  <a:tcPr/>
+                </a:tc>
+              </a:tr>
+            </a:tbl>
+          </a:graphicData>
+        </a:graphic>
+      </p:graphicFrame>
+      <p:sp>
+        <p:nvSpPr>
+          <p:cNvPr id="6" name="Rounded Rectangle 5"/>
           <p:cNvSpPr/>
           <p:nvPr/>
         </p:nvSpPr>
@@ -7284,7 +7682,7 @@
       </p:sp>
       <p:sp>
         <p:nvSpPr>
-          <p:cNvPr id="6" name="TextBox 5"/>
+          <p:cNvPr id="7" name="TextBox 6"/>
           <p:cNvSpPr txBox="1"/>
           <p:nvPr/>
         </p:nvSpPr>
@@ -7318,7 +7716,7 @@
       </p:sp>
       <p:sp>
         <p:nvSpPr>
-          <p:cNvPr id="7" name="TextBox 6"/>
+          <p:cNvPr id="8" name="TextBox 7"/>
           <p:cNvSpPr txBox="1"/>
           <p:nvPr/>
         </p:nvSpPr>
@@ -7352,7 +7750,7 @@
       </p:sp>
       <p:sp>
         <p:nvSpPr>
-          <p:cNvPr id="8" name="TextBox 7"/>
+          <p:cNvPr id="9" name="TextBox 8"/>
           <p:cNvSpPr txBox="1"/>
           <p:nvPr/>
         </p:nvSpPr>
@@ -7386,7 +7784,7 @@
       </p:sp>
       <p:sp>
         <p:nvSpPr>
-          <p:cNvPr id="9" name="TextBox 8"/>
+          <p:cNvPr id="10" name="TextBox 9"/>
           <p:cNvSpPr txBox="1"/>
           <p:nvPr/>
         </p:nvSpPr>
@@ -7420,7 +7818,7 @@
       </p:sp>
       <p:sp>
         <p:nvSpPr>
-          <p:cNvPr id="10" name="TextBox 9"/>
+          <p:cNvPr id="11" name="TextBox 10"/>
           <p:cNvSpPr txBox="1"/>
           <p:nvPr/>
         </p:nvSpPr>
@@ -7455,7 +7853,7 @@
       </p:sp>
       <p:sp>
         <p:nvSpPr>
-          <p:cNvPr id="11" name="TextBox 10"/>
+          <p:cNvPr id="12" name="TextBox 11"/>
           <p:cNvSpPr txBox="1"/>
           <p:nvPr/>
         </p:nvSpPr>
@@ -7489,7 +7887,7 @@
       </p:sp>
       <p:sp>
         <p:nvSpPr>
-          <p:cNvPr id="12" name="TextBox 11"/>
+          <p:cNvPr id="13" name="TextBox 12"/>
           <p:cNvSpPr txBox="1"/>
           <p:nvPr/>
         </p:nvSpPr>
@@ -9858,7 +10256,7 @@
                   <a:srgbClr val="555555"/>
                 </a:solidFill>
               </a:rPr>
-              <a:t>Columns: Invoice · StockCode · Description · Quantity · Price · InvoiceDate · CustomerID · Country</a:t>
+              <a:t>Columns (8, all transaction-level): Invoice · StockCode · Description · Quantity · Price · InvoiceDate · CustomerID · Country</a:t>
             </a:r>
           </a:p>
         </p:txBody>
@@ -9871,8 +10269,8 @@
         </p:nvSpPr>
         <p:spPr>
           <a:xfrm>
-            <a:off x="548640" y="5029200"/>
-            <a:ext cx="10972800" cy="365760"/>
+            <a:off x="548640" y="4983480"/>
+            <a:ext cx="10972800" cy="411480"/>
           </a:xfrm>
           <a:prstGeom prst="rect">
             <a:avLst/>
@@ -9887,12 +10285,12 @@
           <a:p>
             <a:pPr algn="l"/>
             <a:r>
-              <a:rPr sz="1200" b="0">
-                <a:solidFill>
-                  <a:srgbClr val="555555"/>
-                </a:solidFill>
-              </a:rPr>
-              <a:t>Source: https://archive.ics.uci.edu/dataset/502/online+retail+ii</a:t>
+              <a:rPr sz="1200" b="1">
+                <a:solidFill>
+                  <a:srgbClr val="264653"/>
+                </a:solidFill>
+              </a:rPr>
+              <a:t>No customer attributes (name / contact / demographics) exist beyond the CustomerID key — a null CustomerID therefore carries no recoverable customer information.</a:t>
             </a:r>
           </a:p>
         </p:txBody>
@@ -9905,8 +10303,8 @@
         </p:nvSpPr>
         <p:spPr>
           <a:xfrm>
-            <a:off x="365760" y="6446520"/>
-            <a:ext cx="5486400" cy="320040"/>
+            <a:off x="548640" y="5440680"/>
+            <a:ext cx="10972800" cy="365760"/>
           </a:xfrm>
           <a:prstGeom prst="rect">
             <a:avLst/>
@@ -9921,6 +10319,40 @@
           <a:p>
             <a:pPr algn="l"/>
             <a:r>
+              <a:rPr sz="1200" b="0">
+                <a:solidFill>
+                  <a:srgbClr val="555555"/>
+                </a:solidFill>
+              </a:rPr>
+              <a:t>Source: https://archive.ics.uci.edu/dataset/502/online+retail+ii</a:t>
+            </a:r>
+          </a:p>
+        </p:txBody>
+      </p:sp>
+      <p:sp>
+        <p:nvSpPr>
+          <p:cNvPr id="25" name="TextBox 24"/>
+          <p:cNvSpPr txBox="1"/>
+          <p:nvPr/>
+        </p:nvSpPr>
+        <p:spPr>
+          <a:xfrm>
+            <a:off x="365760" y="6446520"/>
+            <a:ext cx="5486400" cy="320040"/>
+          </a:xfrm>
+          <a:prstGeom prst="rect">
+            <a:avLst/>
+          </a:prstGeom>
+          <a:noFill/>
+        </p:spPr>
+        <p:txBody>
+          <a:bodyPr wrap="square">
+            <a:spAutoFit/>
+          </a:bodyPr>
+          <a:lstStyle/>
+          <a:p>
+            <a:pPr algn="l"/>
+            <a:r>
               <a:rPr sz="1000" b="0">
                 <a:solidFill>
                   <a:srgbClr val="555555"/>
@@ -9933,7 +10365,7 @@
       </p:sp>
       <p:sp>
         <p:nvSpPr>
-          <p:cNvPr id="25" name="TextBox 24"/>
+          <p:cNvPr id="26" name="TextBox 25"/>
           <p:cNvSpPr txBox="1"/>
           <p:nvPr/>
         </p:nvSpPr>
@@ -10256,7 +10688,7 @@
                   <a:srgbClr val="555555"/>
                 </a:solidFill>
               </a:rPr>
-              <a:t>From raw 1.07M rows to clean 805K rows</a:t>
+              <a:t>From raw 1.07M rows to clean 805K rows — only 24.5% dropped</a:t>
             </a:r>
           </a:p>
         </p:txBody>
@@ -10269,8 +10701,8 @@
         </p:nvSpPr>
         <p:spPr>
           <a:xfrm>
-            <a:off x="457200" y="1188720"/>
-            <a:ext cx="11247120" cy="2286000"/>
+            <a:off x="457200" y="1143000"/>
+            <a:ext cx="5486400" cy="2560320"/>
           </a:xfrm>
           <a:prstGeom prst="rect">
             <a:avLst/>
@@ -10289,12 +10721,12 @@
               </a:spcAft>
             </a:pPr>
             <a:r>
-              <a:rPr sz="1400">
+              <a:rPr sz="1300">
                 <a:solidFill>
                   <a:srgbClr val="1F1F1F"/>
                 </a:solidFill>
               </a:rPr>
-              <a:t>•  Drop ~25% rows with null CustomerID</a:t>
+              <a:t>•  Drop 22.8% rows with null CustomerID</a:t>
             </a:r>
           </a:p>
           <a:p>
@@ -10304,7 +10736,7 @@
               </a:spcAft>
             </a:pPr>
             <a:r>
-              <a:rPr sz="1400">
+              <a:rPr sz="1300">
                 <a:solidFill>
                   <a:srgbClr val="1F1F1F"/>
                 </a:solidFill>
@@ -10319,7 +10751,7 @@
               </a:spcAft>
             </a:pPr>
             <a:r>
-              <a:rPr sz="1400">
+              <a:rPr sz="1300">
                 <a:solidFill>
                   <a:srgbClr val="1F1F1F"/>
                 </a:solidFill>
@@ -10334,7 +10766,7 @@
               </a:spcAft>
             </a:pPr>
             <a:r>
-              <a:rPr sz="1400">
+              <a:rPr sz="1300">
                 <a:solidFill>
                   <a:srgbClr val="1F1F1F"/>
                 </a:solidFill>
@@ -10349,7 +10781,7 @@
               </a:spcAft>
             </a:pPr>
             <a:r>
-              <a:rPr sz="1400">
+              <a:rPr sz="1300">
                 <a:solidFill>
                   <a:srgbClr val="1F1F1F"/>
                 </a:solidFill>
@@ -10364,7 +10796,7 @@
               </a:spcAft>
             </a:pPr>
             <a:r>
-              <a:rPr sz="1400">
+              <a:rPr sz="1300">
                 <a:solidFill>
                   <a:srgbClr val="1F1F1F"/>
                 </a:solidFill>
@@ -10379,19 +10811,267 @@
               </a:spcAft>
             </a:pPr>
             <a:r>
-              <a:rPr sz="1400">
+              <a:rPr sz="1300">
                 <a:solidFill>
                   <a:srgbClr val="1F1F1F"/>
                 </a:solidFill>
               </a:rPr>
               <a:t>•  Label churn: no activity in 90 d after 2011-09-01</a:t>
+            </a:r>
+          </a:p>
+        </p:txBody>
+      </p:sp>
+      <p:graphicFrame>
+        <p:nvGraphicFramePr>
+          <p:cNvPr id="5" name="Table 4"/>
+          <p:cNvGraphicFramePr>
+            <a:graphicFrameLocks noGrp="1"/>
+          </p:cNvGraphicFramePr>
+          <p:nvPr/>
+        </p:nvGraphicFramePr>
+        <p:xfrm>
+          <a:off x="6217920" y="1234440"/>
+          <a:ext cx="5577840" cy="2011680"/>
+        </p:xfrm>
+        <a:graphic>
+          <a:graphicData uri="http://schemas.openxmlformats.org/drawingml/2006/table">
+            <a:tbl>
+              <a:tblPr firstRow="1" bandRow="1">
+                <a:tableStyleId>{5C22544A-7EE6-4342-B048-85BDC9FD1C3A}</a:tableStyleId>
+              </a:tblPr>
+              <a:tblGrid>
+                <a:gridCol w="2788920"/>
+                <a:gridCol w="2788920"/>
+              </a:tblGrid>
+              <a:tr h="402336">
+                <a:tc>
+                  <a:txBody>
+                    <a:bodyPr/>
+                    <a:lstStyle/>
+                    <a:p>
+                      <a:r>
+                        <a:rPr sz="1300" b="1">
+                          <a:solidFill>
+                            <a:srgbClr val="FFFFFF"/>
+                          </a:solidFill>
+                        </a:rPr>
+                        <a:t>Filter removed</a:t>
+                      </a:r>
+                    </a:p>
+                  </a:txBody>
+                  <a:tcPr>
+                    <a:solidFill>
+                      <a:srgbClr val="264653"/>
+                    </a:solidFill>
+                  </a:tcPr>
+                </a:tc>
+                <a:tc>
+                  <a:txBody>
+                    <a:bodyPr/>
+                    <a:lstStyle/>
+                    <a:p>
+                      <a:r>
+                        <a:rPr sz="1300" b="1">
+                          <a:solidFill>
+                            <a:srgbClr val="FFFFFF"/>
+                          </a:solidFill>
+                        </a:rPr>
+                        <a:t>% of raw rows</a:t>
+                      </a:r>
+                    </a:p>
+                  </a:txBody>
+                  <a:tcPr>
+                    <a:solidFill>
+                      <a:srgbClr val="264653"/>
+                    </a:solidFill>
+                  </a:tcPr>
+                </a:tc>
+              </a:tr>
+              <a:tr h="402336">
+                <a:tc>
+                  <a:txBody>
+                    <a:bodyPr/>
+                    <a:lstStyle/>
+                    <a:p>
+                      <a:r>
+                        <a:rPr sz="1300" b="0">
+                          <a:solidFill>
+                            <a:srgbClr val="1F1F1F"/>
+                          </a:solidFill>
+                        </a:rPr>
+                        <a:t>Missing CustomerID</a:t>
+                      </a:r>
+                    </a:p>
+                  </a:txBody>
+                  <a:tcPr/>
+                </a:tc>
+                <a:tc>
+                  <a:txBody>
+                    <a:bodyPr/>
+                    <a:lstStyle/>
+                    <a:p>
+                      <a:r>
+                        <a:rPr sz="1300" b="0">
+                          <a:solidFill>
+                            <a:srgbClr val="1F1F1F"/>
+                          </a:solidFill>
+                        </a:rPr>
+                        <a:t>22.8%</a:t>
+                      </a:r>
+                    </a:p>
+                  </a:txBody>
+                  <a:tcPr/>
+                </a:tc>
+              </a:tr>
+              <a:tr h="402336">
+                <a:tc>
+                  <a:txBody>
+                    <a:bodyPr/>
+                    <a:lstStyle/>
+                    <a:p>
+                      <a:r>
+                        <a:rPr sz="1300" b="0">
+                          <a:solidFill>
+                            <a:srgbClr val="1F1F1F"/>
+                          </a:solidFill>
+                        </a:rPr>
+                        <a:t>Cancellation invoices (C)</a:t>
+                      </a:r>
+                    </a:p>
+                  </a:txBody>
+                  <a:tcPr/>
+                </a:tc>
+                <a:tc>
+                  <a:txBody>
+                    <a:bodyPr/>
+                    <a:lstStyle/>
+                    <a:p>
+                      <a:r>
+                        <a:rPr sz="1300" b="0">
+                          <a:solidFill>
+                            <a:srgbClr val="1F1F1F"/>
+                          </a:solidFill>
+                        </a:rPr>
+                        <a:t>1.8%</a:t>
+                      </a:r>
+                    </a:p>
+                  </a:txBody>
+                  <a:tcPr/>
+                </a:tc>
+              </a:tr>
+              <a:tr h="402336">
+                <a:tc>
+                  <a:txBody>
+                    <a:bodyPr/>
+                    <a:lstStyle/>
+                    <a:p>
+                      <a:r>
+                        <a:rPr sz="1300" b="0">
+                          <a:solidFill>
+                            <a:srgbClr val="1F1F1F"/>
+                          </a:solidFill>
+                        </a:rPr>
+                        <a:t>Non-positive Qty / Price</a:t>
+                      </a:r>
+                    </a:p>
+                  </a:txBody>
+                  <a:tcPr/>
+                </a:tc>
+                <a:tc>
+                  <a:txBody>
+                    <a:bodyPr/>
+                    <a:lstStyle/>
+                    <a:p>
+                      <a:r>
+                        <a:rPr sz="1300" b="0">
+                          <a:solidFill>
+                            <a:srgbClr val="1F1F1F"/>
+                          </a:solidFill>
+                        </a:rPr>
+                        <a:t>2.4%</a:t>
+                      </a:r>
+                    </a:p>
+                  </a:txBody>
+                  <a:tcPr/>
+                </a:tc>
+              </a:tr>
+              <a:tr h="402336">
+                <a:tc>
+                  <a:txBody>
+                    <a:bodyPr/>
+                    <a:lstStyle/>
+                    <a:p>
+                      <a:r>
+                        <a:rPr sz="1300" b="1">
+                          <a:solidFill>
+                            <a:srgbClr val="1F1F1F"/>
+                          </a:solidFill>
+                        </a:rPr>
+                        <a:t>Total rows removed</a:t>
+                      </a:r>
+                    </a:p>
+                  </a:txBody>
+                  <a:tcPr/>
+                </a:tc>
+                <a:tc>
+                  <a:txBody>
+                    <a:bodyPr/>
+                    <a:lstStyle/>
+                    <a:p>
+                      <a:r>
+                        <a:rPr sz="1300" b="1">
+                          <a:solidFill>
+                            <a:srgbClr val="1F1F1F"/>
+                          </a:solidFill>
+                        </a:rPr>
+                        <a:t>24.5%</a:t>
+                      </a:r>
+                    </a:p>
+                  </a:txBody>
+                  <a:tcPr/>
+                </a:tc>
+              </a:tr>
+            </a:tbl>
+          </a:graphicData>
+        </a:graphic>
+      </p:graphicFrame>
+      <p:sp>
+        <p:nvSpPr>
+          <p:cNvPr id="6" name="TextBox 5"/>
+          <p:cNvSpPr txBox="1"/>
+          <p:nvPr/>
+        </p:nvSpPr>
+        <p:spPr>
+          <a:xfrm>
+            <a:off x="6217920" y="3337560"/>
+            <a:ext cx="5577840" cy="822960"/>
+          </a:xfrm>
+          <a:prstGeom prst="rect">
+            <a:avLst/>
+          </a:prstGeom>
+          <a:noFill/>
+        </p:spPr>
+        <p:txBody>
+          <a:bodyPr wrap="square">
+            <a:spAutoFit/>
+          </a:bodyPr>
+          <a:lstStyle/>
+          <a:p>
+            <a:pPr algn="l"/>
+            <a:r>
+              <a:rPr sz="1200" b="1">
+                <a:solidFill>
+                  <a:srgbClr val="264653"/>
+                </a:solidFill>
+              </a:rPr>
+              <a:t>Dropping null-CustomerID rows is mandatory (RFM / churn are per-customer) yet costs only 3.5% of units &amp; 13.7% of revenue — almost no purchasing signal lost.</a:t>
             </a:r>
           </a:p>
         </p:txBody>
       </p:sp>
       <p:pic>
         <p:nvPicPr>
-          <p:cNvPr id="5" name="Picture 4" descr="01_distributions.png"/>
+          <p:cNvPr id="7" name="Picture 6" descr="01_distributions.png"/>
           <p:cNvPicPr>
             <a:picLocks noChangeAspect="1"/>
           </p:cNvPicPr>
@@ -10405,8 +11085,8 @@
         </p:blipFill>
         <p:spPr>
           <a:xfrm>
-            <a:off x="1984248" y="3611880"/>
-            <a:ext cx="8229600" cy="2564608"/>
+            <a:off x="3081528" y="4206240"/>
+            <a:ext cx="6035040" cy="1880712"/>
           </a:xfrm>
           <a:prstGeom prst="rect">
             <a:avLst/>
@@ -10415,7 +11095,7 @@
       </p:pic>
       <p:sp>
         <p:nvSpPr>
-          <p:cNvPr id="6" name="TextBox 5"/>
+          <p:cNvPr id="8" name="TextBox 7"/>
           <p:cNvSpPr txBox="1"/>
           <p:nvPr/>
         </p:nvSpPr>
@@ -10449,7 +11129,7 @@
       </p:sp>
       <p:sp>
         <p:nvSpPr>
-          <p:cNvPr id="7" name="TextBox 6"/>
+          <p:cNvPr id="9" name="TextBox 8"/>
           <p:cNvSpPr txBox="1"/>
           <p:nvPr/>
         </p:nvSpPr>
@@ -10483,7 +11163,7 @@
       </p:sp>
       <p:sp>
         <p:nvSpPr>
-          <p:cNvPr id="8" name="TextBox 7"/>
+          <p:cNvPr id="10" name="TextBox 9"/>
           <p:cNvSpPr txBox="1"/>
           <p:nvPr/>
         </p:nvSpPr>

</xml_diff>